<commit_message>
D-3: bracket the client facts the deck asserted as true
Slide 4 stated a former trading name and two social handles as fact. All three
come from docs/research/boy-concept-brief.md, whose own header says not to copy
names into pitch material, and one handle is contradicted by a second candidate
Ademola quoted on 2026-10-10. Now [Confirm the trading name] and [Confirm both
handles], matching the deck's existing [Confirm ...] convention.

Slide 6 promised silent hover previews. ARCHITECTURE 9 puts video on tap,
DESIGN 8 bans autoplaying iframes, and most visitors arrive on a phone with no
hover at all. Changed to poster-first cards.

Nothing was invented to replace those claims. The deck's own brackets are now
registered in a Pitch material section of the register.
</commit_message>
<xml_diff>
--- a/pitch/Alpha_Movies_Proposal.pptx
+++ b/pitch/Alpha_Movies_Proposal.pptx
@@ -3453,7 +3453,7 @@
                 <a:ea typeface="Arial" pitchFamily="34" charset="-122"/>
                 <a:cs typeface="Arial" pitchFamily="34" charset="-120"/>
               </a:rPr>
-              <a:t>Alpha Movies Ltd (formerly Tue Tue Concept)</a:t>
+              <a:t>Alpha Movies Ltd (formerly [Confirm the trading name])</a:t>
             </a:r>
             <a:endParaRPr lang="en-US" sz="1400" dirty="0"/>
           </a:p>
@@ -3958,7 +3958,7 @@
                 <a:ea typeface="Arial" pitchFamily="34" charset="-122"/>
                 <a:cs typeface="Arial" pitchFamily="34" charset="-120"/>
               </a:rPr>
-              <a:t>Instagram @alpha.movies_ and YouTube @Boy-concept</a:t>
+              <a:t>Instagram and YouTube [Confirm both handles]</a:t>
             </a:r>
             <a:endParaRPr lang="en-US" sz="1400" dirty="0"/>
           </a:p>
@@ -5113,7 +5113,7 @@
                 <a:ea typeface="Arial" pitchFamily="34" charset="-122"/>
                 <a:cs typeface="Arial" pitchFamily="34" charset="-120"/>
               </a:rPr>
-              <a:t>A dark, fast-loading showcase sorted into Commercial, Cultural Festivals, Weddings and Documentaries. One hero reel, silent hover previews, and a player that holds quality better than a social feed.</a:t>
+              <a:t>A dark, fast-loading showcase sorted into Commercial, Cultural Festivals, Weddings and Documentaries. One hero reel, poster-first cards, and a player that holds quality better than a social feed.</a:t>
             </a:r>
             <a:endParaRPr lang="en-US" sz="1400" dirty="0"/>
           </a:p>

</xml_diff>